<commit_message>
Presentation: prototype photo to the outline, space held for the finished product
The bring-up photo now sits beside the outline as the early prototype. The
results slide keeps a marked box of the same size for the finished-product
photo, captioned to match.

Co-Authored-By: Claude Opus 5.5 <noreply@anthropic.com>
</commit_message>
<xml_diff>
--- a/presentation/ESDL_Project1_Presentation.pptx
+++ b/presentation/ESDL_Project1_Presentation.pptx
@@ -8582,20 +8582,12 @@
           </a:p>
         </p:txBody>
       </p:sp>
-      <p:pic>
-        <p:nvPicPr>
-          <p:cNvPr id="30" name="Prototype Photo" descr="Top-down photo of the breadboard prototype with the ESP32, fan driver and OLED panels reading 75.9 and 75.7 F"/>
-          <p:cNvPicPr>
-            <a:picLocks noChangeAspect="1"/>
-          </p:cNvPicPr>
+      <p:sp>
+        <p:nvSpPr>
+          <p:cNvPr id="30" name="Finished Product Photo"/>
+          <p:cNvSpPr/>
           <p:nvPr/>
-        </p:nvPicPr>
-        <p:blipFill>
-          <a:blip r:embed="rId30"/>
-          <a:stretch>
-            <a:fillRect/>
-          </a:stretch>
-        </p:blipFill>
+        </p:nvSpPr>
         <p:spPr>
           <a:xfrm>
             <a:off x="420624" y="1572768"/>
@@ -8604,8 +8596,39 @@
           <a:prstGeom prst="rect">
             <a:avLst/>
           </a:prstGeom>
-        </p:spPr>
-      </p:pic>
+          <a:solidFill>
+            <a:srgbClr val="F2F2F2"/>
+          </a:solidFill>
+          <a:ln w="19050">
+            <a:solidFill>
+              <a:srgbClr val="7F7F7F"/>
+            </a:solidFill>
+            <a:prstDash val="dash"/>
+          </a:ln>
+        </p:spPr>
+        <p:txBody>
+          <a:bodyPr wrap="square" lIns="91440" tIns="45720" rIns="91440" bIns="45720" anchor="ctr">
+            <a:noAutofit/>
+          </a:bodyPr>
+          <a:lstStyle/>
+          <a:p>
+            <a:pPr algn="ctr">
+              <a:buNone/>
+            </a:pPr>
+            <a:r>
+              <a:rPr lang="en-US" sz="1800" b="1" dirty="0">
+                <a:solidFill>
+                  <a:srgbClr val="595959"/>
+                </a:solidFill>
+                <a:latin typeface="Times New Roman"/>
+                <a:ea typeface="Times New Roman"/>
+                <a:cs typeface="Times New Roman"/>
+              </a:rPr>
+              <a:t>Finished product photo</a:t>
+            </a:r>
+          </a:p>
+        </p:txBody>
+      </p:sp>
       <p:sp>
         <p:nvSpPr>
           <p:cNvPr id="31" name="Photo Caption"/>
@@ -8643,7 +8666,7 @@
                 <a:ea typeface="Times New Roman"/>
                 <a:cs typeface="Times New Roman"/>
               </a:rPr>
-              <a:t>Prototype on the bench</a:t>
+              <a:t>Finished product</a:t>
             </a:r>
           </a:p>
         </p:txBody>
@@ -10393,7 +10416,7 @@
         <p:spPr>
           <a:xfrm>
             <a:off x="685800" y="1463040"/>
-            <a:ext cx="10789920" cy="4846320"/>
+            <a:ext cx="6035040" cy="4846320"/>
           </a:xfrm>
           <a:prstGeom prst="rect">
             <a:avLst/>
@@ -10648,6 +10671,72 @@
                 <a:cs typeface="Times New Roman"/>
               </a:rPr>
               <a:t>2</a:t>
+            </a:r>
+          </a:p>
+        </p:txBody>
+      </p:sp>
+      <p:pic>
+        <p:nvPicPr>
+          <p:cNvPr id="20" name="Prototype Photo" descr="Top-down photo of the early breadboard prototype with the ESP32, fan driver and OLED panels reading 75.9 and 75.7 F"/>
+          <p:cNvPicPr>
+            <a:picLocks noChangeAspect="1"/>
+          </p:cNvPicPr>
+          <p:nvPr/>
+        </p:nvPicPr>
+        <p:blipFill>
+          <a:blip r:embed="rId20"/>
+          <a:stretch>
+            <a:fillRect/>
+          </a:stretch>
+        </p:blipFill>
+        <p:spPr>
+          <a:xfrm>
+            <a:off x="6949440" y="1463040"/>
+            <a:ext cx="4818888" cy="3614166"/>
+          </a:xfrm>
+          <a:prstGeom prst="rect">
+            <a:avLst/>
+          </a:prstGeom>
+        </p:spPr>
+      </p:pic>
+      <p:sp>
+        <p:nvSpPr>
+          <p:cNvPr id="21" name="Photo Caption"/>
+          <p:cNvSpPr txBox="1"/>
+          <p:nvPr/>
+        </p:nvSpPr>
+        <p:spPr>
+          <a:xfrm>
+            <a:off x="6949440" y="5166360"/>
+            <a:ext cx="4818888" cy="329184"/>
+          </a:xfrm>
+          <a:prstGeom prst="rect">
+            <a:avLst/>
+          </a:prstGeom>
+          <a:noFill/>
+          <a:ln w="0">
+            <a:noFill/>
+          </a:ln>
+        </p:spPr>
+        <p:txBody>
+          <a:bodyPr wrap="square" lIns="0" tIns="0" rIns="0" bIns="0">
+            <a:noAutofit/>
+          </a:bodyPr>
+          <a:lstStyle/>
+          <a:p>
+            <a:pPr algn="l">
+              <a:buNone/>
+            </a:pPr>
+            <a:r>
+              <a:rPr lang="en-US" sz="1800" b="1" dirty="0">
+                <a:solidFill>
+                  <a:srgbClr val="000000"/>
+                </a:solidFill>
+                <a:latin typeface="Times New Roman"/>
+                <a:ea typeface="Times New Roman"/>
+                <a:cs typeface="Times New Roman"/>
+              </a:rPr>
+              <a:t>Early prototype on the bench</a:t>
             </a:r>
           </a:p>
         </p:txBody>

</xml_diff>